<commit_message>
Use the designer vertical lockup for Английский Маяк.
Redraw the lighthouse mark (white tower, gold beams) and rebuild PDF/PPTX templates plus course files so the logo matches the colored name+icon variant.

Co-authored-by: munlightshadow <munlightshadow@users.noreply.github.com>
</commit_message>
<xml_diff>
--- a/ege-english-course/brand/шаблон-презентации.pptx
+++ b/ege-english-course/brand/шаблон-презентации.pptx
@@ -3329,8 +3329,8 @@
         </p:blipFill>
         <p:spPr>
           <a:xfrm>
-            <a:off x="4948152" y="502920"/>
-            <a:ext cx="2295390" cy="1691640"/>
+            <a:off x="4935362" y="502920"/>
+            <a:ext cx="2320970" cy="1691640"/>
           </a:xfrm>
           <a:prstGeom prst="rect">
             <a:avLst/>
@@ -4292,7 +4292,7 @@
         <p:spPr>
           <a:xfrm>
             <a:off x="9464040" y="146304"/>
-            <a:ext cx="1460676" cy="384048"/>
+            <a:ext cx="1530063" cy="384048"/>
           </a:xfrm>
           <a:prstGeom prst="rect">
             <a:avLst/>
@@ -5027,7 +5027,7 @@
         <p:spPr>
           <a:xfrm>
             <a:off x="9464040" y="146304"/>
-            <a:ext cx="1460676" cy="384048"/>
+            <a:ext cx="1530063" cy="384048"/>
           </a:xfrm>
           <a:prstGeom prst="rect">
             <a:avLst/>
@@ -5780,7 +5780,7 @@
         <p:spPr>
           <a:xfrm>
             <a:off x="9464040" y="146304"/>
-            <a:ext cx="1460676" cy="384048"/>
+            <a:ext cx="1530063" cy="384048"/>
           </a:xfrm>
           <a:prstGeom prst="rect">
             <a:avLst/>
@@ -6515,7 +6515,7 @@
         <p:spPr>
           <a:xfrm>
             <a:off x="9464040" y="146304"/>
-            <a:ext cx="1460676" cy="384048"/>
+            <a:ext cx="1530063" cy="384048"/>
           </a:xfrm>
           <a:prstGeom prst="rect">
             <a:avLst/>

</xml_diff>

<commit_message>
Use the designer Frame 4 vector logo in PDF and PPTX templates.
Keep the original 2500-pt PDF as the source and export the circular mark plus vertical and horizontal lockups from it, replacing the hand-drawn stand-in.

Co-authored-by: munlightshadow <munlightshadow@users.noreply.github.com>
</commit_message>
<xml_diff>
--- a/ege-english-course/brand/шаблон-презентации.pptx
+++ b/ege-english-course/brand/шаблон-презентации.pptx
@@ -3329,8 +3329,8 @@
         </p:blipFill>
         <p:spPr>
           <a:xfrm>
-            <a:off x="4935362" y="502920"/>
-            <a:ext cx="2320970" cy="1691640"/>
+            <a:off x="4975063" y="502920"/>
+            <a:ext cx="2241568" cy="1691640"/>
           </a:xfrm>
           <a:prstGeom prst="rect">
             <a:avLst/>
@@ -4291,8 +4291,8 @@
         </p:blipFill>
         <p:spPr>
           <a:xfrm>
-            <a:off x="9464040" y="146304"/>
-            <a:ext cx="1530063" cy="384048"/>
+            <a:off x="9525351" y="146304"/>
+            <a:ext cx="2190856" cy="365760"/>
           </a:xfrm>
           <a:prstGeom prst="rect">
             <a:avLst/>
@@ -5026,8 +5026,8 @@
         </p:blipFill>
         <p:spPr>
           <a:xfrm>
-            <a:off x="9464040" y="146304"/>
-            <a:ext cx="1530063" cy="384048"/>
+            <a:off x="9525351" y="146304"/>
+            <a:ext cx="2190856" cy="365760"/>
           </a:xfrm>
           <a:prstGeom prst="rect">
             <a:avLst/>
@@ -5779,8 +5779,8 @@
         </p:blipFill>
         <p:spPr>
           <a:xfrm>
-            <a:off x="9464040" y="146304"/>
-            <a:ext cx="1530063" cy="384048"/>
+            <a:off x="9525351" y="146304"/>
+            <a:ext cx="2190856" cy="365760"/>
           </a:xfrm>
           <a:prstGeom prst="rect">
             <a:avLst/>
@@ -6514,8 +6514,8 @@
         </p:blipFill>
         <p:spPr>
           <a:xfrm>
-            <a:off x="9464040" y="146304"/>
-            <a:ext cx="1530063" cy="384048"/>
+            <a:off x="9525351" y="146304"/>
+            <a:ext cx="2190856" cy="365760"/>
           </a:xfrm>
           <a:prstGeom prst="rect">
             <a:avLst/>

</xml_diff>

<commit_message>
Add contrast lighthouse mark and a brand-blue title slide.
Use the dark lockup on light pages, the pale disc on dark section slides, and a teal gradient title with a white-and-gold lighthouse in the corner.

Co-authored-by: munlightshadow <munlightshadow@users.noreply.github.com>
</commit_message>
<xml_diff>
--- a/ege-english-course/brand/шаблон-презентации.pptx
+++ b/ege-english-course/brand/шаблон-презентации.pptx
@@ -3093,229 +3093,9 @@
         <p:nvPr/>
       </p:nvGrpSpPr>
       <p:grpSpPr/>
-      <p:sp>
-        <p:nvSpPr>
-          <p:cNvPr id="2" name="Rectangle 1"/>
-          <p:cNvSpPr/>
-          <p:nvPr/>
-        </p:nvSpPr>
-        <p:spPr>
-          <a:xfrm>
-            <a:off x="0" y="0"/>
-            <a:ext cx="12191695" cy="6858000"/>
-          </a:xfrm>
-          <a:prstGeom prst="rect">
-            <a:avLst/>
-          </a:prstGeom>
-          <a:solidFill>
-            <a:srgbClr val="FFFFFF"/>
-          </a:solidFill>
-          <a:ln>
-            <a:noFill/>
-          </a:ln>
-          <a:effectLst/>
-        </p:spPr>
-        <p:style>
-          <a:lnRef idx="1">
-            <a:schemeClr val="accent1"/>
-          </a:lnRef>
-          <a:fillRef idx="3">
-            <a:schemeClr val="accent1"/>
-          </a:fillRef>
-          <a:effectRef idx="2">
-            <a:schemeClr val="accent1"/>
-          </a:effectRef>
-          <a:fontRef idx="minor">
-            <a:schemeClr val="lt1"/>
-          </a:fontRef>
-        </p:style>
-        <p:txBody>
-          <a:bodyPr rtlCol="0" anchor="ctr"/>
-          <a:lstStyle/>
-          <a:p>
-            <a:pPr algn="ctr"/>
-          </a:p>
-        </p:txBody>
-      </p:sp>
-      <p:sp>
-        <p:nvSpPr>
-          <p:cNvPr id="3" name="Rectangle 2"/>
-          <p:cNvSpPr/>
-          <p:nvPr/>
-        </p:nvSpPr>
-        <p:spPr>
-          <a:xfrm>
-            <a:off x="0" y="0"/>
-            <a:ext cx="12191695" cy="41148"/>
-          </a:xfrm>
-          <a:prstGeom prst="rect">
-            <a:avLst/>
-          </a:prstGeom>
-          <a:solidFill>
-            <a:srgbClr val="C19B4F"/>
-          </a:solidFill>
-          <a:ln>
-            <a:noFill/>
-          </a:ln>
-          <a:effectLst/>
-        </p:spPr>
-        <p:style>
-          <a:lnRef idx="1">
-            <a:schemeClr val="accent1"/>
-          </a:lnRef>
-          <a:fillRef idx="3">
-            <a:schemeClr val="accent1"/>
-          </a:fillRef>
-          <a:effectRef idx="2">
-            <a:schemeClr val="accent1"/>
-          </a:effectRef>
-          <a:fontRef idx="minor">
-            <a:schemeClr val="lt1"/>
-          </a:fontRef>
-        </p:style>
-        <p:txBody>
-          <a:bodyPr rtlCol="0" anchor="ctr"/>
-          <a:lstStyle/>
-          <a:p>
-            <a:pPr algn="ctr"/>
-          </a:p>
-        </p:txBody>
-      </p:sp>
-      <p:sp>
-        <p:nvSpPr>
-          <p:cNvPr id="4" name="Rectangle 3"/>
-          <p:cNvSpPr/>
-          <p:nvPr/>
-        </p:nvSpPr>
-        <p:spPr>
-          <a:xfrm>
-            <a:off x="0" y="41148"/>
-            <a:ext cx="12191695" cy="64008"/>
-          </a:xfrm>
-          <a:prstGeom prst="rect">
-            <a:avLst/>
-          </a:prstGeom>
-          <a:solidFill>
-            <a:srgbClr val="214149"/>
-          </a:solidFill>
-          <a:ln>
-            <a:noFill/>
-          </a:ln>
-          <a:effectLst/>
-        </p:spPr>
-        <p:style>
-          <a:lnRef idx="1">
-            <a:schemeClr val="accent1"/>
-          </a:lnRef>
-          <a:fillRef idx="3">
-            <a:schemeClr val="accent1"/>
-          </a:fillRef>
-          <a:effectRef idx="2">
-            <a:schemeClr val="accent1"/>
-          </a:effectRef>
-          <a:fontRef idx="minor">
-            <a:schemeClr val="lt1"/>
-          </a:fontRef>
-        </p:style>
-        <p:txBody>
-          <a:bodyPr rtlCol="0" anchor="ctr"/>
-          <a:lstStyle/>
-          <a:p>
-            <a:pPr algn="ctr"/>
-          </a:p>
-        </p:txBody>
-      </p:sp>
-      <p:sp>
-        <p:nvSpPr>
-          <p:cNvPr id="5" name="Rectangle 4"/>
-          <p:cNvSpPr/>
-          <p:nvPr/>
-        </p:nvSpPr>
-        <p:spPr>
-          <a:xfrm>
-            <a:off x="0" y="6793992"/>
-            <a:ext cx="12191695" cy="64008"/>
-          </a:xfrm>
-          <a:prstGeom prst="rect">
-            <a:avLst/>
-          </a:prstGeom>
-          <a:solidFill>
-            <a:srgbClr val="214149"/>
-          </a:solidFill>
-          <a:ln>
-            <a:noFill/>
-          </a:ln>
-          <a:effectLst/>
-        </p:spPr>
-        <p:style>
-          <a:lnRef idx="1">
-            <a:schemeClr val="accent1"/>
-          </a:lnRef>
-          <a:fillRef idx="3">
-            <a:schemeClr val="accent1"/>
-          </a:fillRef>
-          <a:effectRef idx="2">
-            <a:schemeClr val="accent1"/>
-          </a:effectRef>
-          <a:fontRef idx="minor">
-            <a:schemeClr val="lt1"/>
-          </a:fontRef>
-        </p:style>
-        <p:txBody>
-          <a:bodyPr rtlCol="0" anchor="ctr"/>
-          <a:lstStyle/>
-          <a:p>
-            <a:pPr algn="ctr"/>
-          </a:p>
-        </p:txBody>
-      </p:sp>
-      <p:sp>
-        <p:nvSpPr>
-          <p:cNvPr id="6" name="Rectangle 5"/>
-          <p:cNvSpPr/>
-          <p:nvPr/>
-        </p:nvSpPr>
-        <p:spPr>
-          <a:xfrm>
-            <a:off x="0" y="6766560"/>
-            <a:ext cx="12191695" cy="27432"/>
-          </a:xfrm>
-          <a:prstGeom prst="rect">
-            <a:avLst/>
-          </a:prstGeom>
-          <a:solidFill>
-            <a:srgbClr val="C19B4F"/>
-          </a:solidFill>
-          <a:ln>
-            <a:noFill/>
-          </a:ln>
-          <a:effectLst/>
-        </p:spPr>
-        <p:style>
-          <a:lnRef idx="1">
-            <a:schemeClr val="accent1"/>
-          </a:lnRef>
-          <a:fillRef idx="3">
-            <a:schemeClr val="accent1"/>
-          </a:fillRef>
-          <a:effectRef idx="2">
-            <a:schemeClr val="accent1"/>
-          </a:effectRef>
-          <a:fontRef idx="minor">
-            <a:schemeClr val="lt1"/>
-          </a:fontRef>
-        </p:style>
-        <p:txBody>
-          <a:bodyPr rtlCol="0" anchor="ctr"/>
-          <a:lstStyle/>
-          <a:p>
-            <a:pPr algn="ctr"/>
-          </a:p>
-        </p:txBody>
-      </p:sp>
       <p:pic>
         <p:nvPicPr>
-          <p:cNvPr id="7" name="Picture 6" descr="logo-stack.png"/>
+          <p:cNvPr id="2" name="Picture 1" descr="cover-bg.png"/>
           <p:cNvPicPr>
             <a:picLocks noChangeAspect="1"/>
           </p:cNvPicPr>
@@ -3329,8 +3109,8 @@
         </p:blipFill>
         <p:spPr>
           <a:xfrm>
-            <a:off x="4975063" y="502920"/>
-            <a:ext cx="2241568" cy="1691640"/>
+            <a:off x="0" y="0"/>
+            <a:ext cx="12191695" cy="6858000"/>
           </a:xfrm>
           <a:prstGeom prst="rect">
             <a:avLst/>
@@ -3339,14 +3119,14 @@
       </p:pic>
       <p:sp>
         <p:nvSpPr>
-          <p:cNvPr id="8" name="TextBox 7"/>
+          <p:cNvPr id="3" name="TextBox 2"/>
           <p:cNvSpPr txBox="1"/>
           <p:nvPr/>
         </p:nvSpPr>
         <p:spPr>
           <a:xfrm>
-            <a:off x="822960" y="2331720"/>
-            <a:ext cx="10515600" cy="822960"/>
+            <a:off x="777240" y="1965960"/>
+            <a:ext cx="6766560" cy="914400"/>
           </a:xfrm>
           <a:prstGeom prst="rect">
             <a:avLst/>
@@ -3357,7 +3137,7 @@
           <a:bodyPr wrap="square" anchor="ctr"/>
           <a:lstStyle/>
           <a:p>
-            <a:pPr algn="ctr">
+            <a:pPr algn="l">
               <a:spcAft>
                 <a:spcPts val="0"/>
               </a:spcAft>
@@ -3365,7 +3145,7 @@
             <a:r>
               <a:rPr sz="3200" b="1" i="0">
                 <a:solidFill>
-                  <a:srgbClr val="214149"/>
+                  <a:srgbClr val="FFFFFF"/>
                 </a:solidFill>
                 <a:latin typeface="Calibri"/>
                 <a:ea typeface="Calibri"/>
@@ -3378,14 +3158,14 @@
       </p:sp>
       <p:sp>
         <p:nvSpPr>
-          <p:cNvPr id="9" name="TextBox 8"/>
+          <p:cNvPr id="4" name="TextBox 3"/>
           <p:cNvSpPr txBox="1"/>
           <p:nvPr/>
         </p:nvSpPr>
         <p:spPr>
           <a:xfrm>
-            <a:off x="1280160" y="3200400"/>
-            <a:ext cx="9601200" cy="457200"/>
+            <a:off x="777240" y="3063240"/>
+            <a:ext cx="6766560" cy="411480"/>
           </a:xfrm>
           <a:prstGeom prst="rect">
             <a:avLst/>
@@ -3396,7 +3176,7 @@
           <a:bodyPr wrap="square" anchor="t"/>
           <a:lstStyle/>
           <a:p>
-            <a:pPr algn="ctr">
+            <a:pPr algn="l">
               <a:spcAft>
                 <a:spcPts val="0"/>
               </a:spcAft>
@@ -3404,7 +3184,7 @@
             <a:r>
               <a:rPr sz="1600" b="0" i="0">
                 <a:solidFill>
-                  <a:srgbClr val="494F55"/>
+                  <a:srgbClr val="A5D2DF"/>
                 </a:solidFill>
                 <a:latin typeface="Calibri"/>
                 <a:ea typeface="Calibri"/>
@@ -3417,14 +3197,14 @@
       </p:sp>
       <p:sp>
         <p:nvSpPr>
-          <p:cNvPr id="10" name="TextBox 9"/>
+          <p:cNvPr id="5" name="TextBox 4"/>
           <p:cNvSpPr txBox="1"/>
           <p:nvPr/>
         </p:nvSpPr>
         <p:spPr>
           <a:xfrm>
-            <a:off x="1280160" y="3794760"/>
-            <a:ext cx="9601200" cy="365760"/>
+            <a:off x="777240" y="3566160"/>
+            <a:ext cx="6766560" cy="365760"/>
           </a:xfrm>
           <a:prstGeom prst="rect">
             <a:avLst/>
@@ -3435,7 +3215,7 @@
           <a:bodyPr wrap="square" anchor="t"/>
           <a:lstStyle/>
           <a:p>
-            <a:pPr algn="ctr">
+            <a:pPr algn="l">
               <a:spcAft>
                 <a:spcPts val="0"/>
               </a:spcAft>
@@ -3443,7 +3223,7 @@
             <a:r>
               <a:rPr sz="1400" b="0" i="0">
                 <a:solidFill>
-                  <a:srgbClr val="468A9D"/>
+                  <a:srgbClr val="F3D593"/>
                 </a:solidFill>
                 <a:latin typeface="Calibri"/>
                 <a:ea typeface="Calibri"/>
@@ -3454,39 +3234,15 @@
           </a:p>
         </p:txBody>
       </p:sp>
-      <p:pic>
-        <p:nvPicPr>
-          <p:cNvPr id="11" name="Picture 10" descr="logo-icon.png"/>
-          <p:cNvPicPr>
-            <a:picLocks noChangeAspect="1"/>
-          </p:cNvPicPr>
-          <p:nvPr/>
-        </p:nvPicPr>
-        <p:blipFill>
-          <a:blip r:embed="rId3"/>
-          <a:stretch>
-            <a:fillRect/>
-          </a:stretch>
-        </p:blipFill>
-        <p:spPr>
-          <a:xfrm>
-            <a:off x="475488" y="6437376"/>
-            <a:ext cx="292608" cy="292608"/>
-          </a:xfrm>
-          <a:prstGeom prst="rect">
-            <a:avLst/>
-          </a:prstGeom>
-        </p:spPr>
-      </p:pic>
-      <p:sp>
-        <p:nvSpPr>
-          <p:cNvPr id="12" name="TextBox 11"/>
+      <p:sp>
+        <p:nvSpPr>
+          <p:cNvPr id="6" name="TextBox 5"/>
           <p:cNvSpPr txBox="1"/>
           <p:nvPr/>
         </p:nvSpPr>
         <p:spPr>
           <a:xfrm>
-            <a:off x="868680" y="6473952"/>
+            <a:off x="502920" y="6473952"/>
             <a:ext cx="8412480" cy="219456"/>
           </a:xfrm>
           <a:prstGeom prst="rect">
@@ -3506,7 +3262,7 @@
             <a:r>
               <a:rPr sz="1000" b="0" i="0">
                 <a:solidFill>
-                  <a:srgbClr val="A8B2BB"/>
+                  <a:srgbClr val="A5D2DF"/>
                 </a:solidFill>
                 <a:latin typeface="Calibri"/>
                 <a:ea typeface="Calibri"/>
@@ -3519,7 +3275,7 @@
       </p:sp>
       <p:sp>
         <p:nvSpPr>
-          <p:cNvPr id="13" name="TextBox 12"/>
+          <p:cNvPr id="7" name="TextBox 6"/>
           <p:cNvSpPr txBox="1"/>
           <p:nvPr/>
         </p:nvSpPr>
@@ -3545,7 +3301,7 @@
             <a:r>
               <a:rPr sz="1100" b="0" i="0">
                 <a:solidFill>
-                  <a:srgbClr val="A8B2BB"/>
+                  <a:srgbClr val="A5D2DF"/>
                 </a:solidFill>
                 <a:latin typeface="Calibri"/>
                 <a:ea typeface="Calibri"/>
@@ -3796,7 +3552,7 @@
       </p:sp>
       <p:pic>
         <p:nvPicPr>
-          <p:cNvPr id="7" name="Picture 6" descr="logo-icon.png"/>
+          <p:cNvPr id="7" name="Picture 6" descr="logo-icon-on-dark.png"/>
           <p:cNvPicPr>
             <a:picLocks noChangeAspect="1"/>
           </p:cNvPicPr>
@@ -3937,7 +3693,7 @@
       </p:sp>
       <p:pic>
         <p:nvPicPr>
-          <p:cNvPr id="11" name="Picture 10" descr="logo-icon.png"/>
+          <p:cNvPr id="11" name="Picture 10" descr="logo-icon-on-dark.png"/>
           <p:cNvPicPr>
             <a:picLocks noChangeAspect="1"/>
           </p:cNvPicPr>

</xml_diff>

<commit_message>
Rebuild PDFs and PPTX with logos cropped from the designer PDF pages.
Co-authored-by: munlightshadow <munlightshadow@users.noreply.github.com>
</commit_message>
<xml_diff>
--- a/ege-english-course/brand/шаблон-презентации.pptx
+++ b/ege-english-course/brand/шаблон-презентации.pptx
@@ -4047,8 +4047,8 @@
         </p:blipFill>
         <p:spPr>
           <a:xfrm>
-            <a:off x="9525351" y="146304"/>
-            <a:ext cx="2190856" cy="365760"/>
+            <a:off x="9519787" y="146304"/>
+            <a:ext cx="2196419" cy="365760"/>
           </a:xfrm>
           <a:prstGeom prst="rect">
             <a:avLst/>
@@ -4782,8 +4782,8 @@
         </p:blipFill>
         <p:spPr>
           <a:xfrm>
-            <a:off x="9525351" y="146304"/>
-            <a:ext cx="2190856" cy="365760"/>
+            <a:off x="9519787" y="146304"/>
+            <a:ext cx="2196419" cy="365760"/>
           </a:xfrm>
           <a:prstGeom prst="rect">
             <a:avLst/>
@@ -5535,8 +5535,8 @@
         </p:blipFill>
         <p:spPr>
           <a:xfrm>
-            <a:off x="9525351" y="146304"/>
-            <a:ext cx="2190856" cy="365760"/>
+            <a:off x="9519787" y="146304"/>
+            <a:ext cx="2196419" cy="365760"/>
           </a:xfrm>
           <a:prstGeom prst="rect">
             <a:avLst/>
@@ -6270,8 +6270,8 @@
         </p:blipFill>
         <p:spPr>
           <a:xfrm>
-            <a:off x="9525351" y="146304"/>
-            <a:ext cx="2190856" cy="365760"/>
+            <a:off x="9519787" y="146304"/>
+            <a:ext cx="2196419" cy="365760"/>
           </a:xfrm>
           <a:prstGeom prst="rect">
             <a:avLst/>

</xml_diff>